<commit_message>
Revise the main document to clarify the factors affecting donor progression to the confirmatory typing (CT) stage, emphasizing the roles of positive intention at response and donor-related dropout. Update the flowchart to reflect changes in the analysis sample and dropout categories. Enhance the R6 class to support outcome labeling in regression tables. Render updated Rmd, LaTeX, and flowchart files.
</commit_message>
<xml_diff>
--- a/image/flowchart.pptx
+++ b/image/flowchart.pptx
@@ -197,7 +197,7 @@
           <a:p>
             <a:fld id="{AE391BAF-91F8-4B50-BA74-917754362F3D}" type="datetimeFigureOut">
               <a:rPr kumimoji="1" lang="ja-JP" altLang="en-US" smtClean="0"/>
-              <a:t>2025/10/29</a:t>
+              <a:t>2026/3/7</a:t>
             </a:fld>
             <a:endParaRPr kumimoji="1" lang="ja-JP" altLang="en-US"/>
           </a:p>
@@ -711,7 +711,7 @@
           <a:p>
             <a:fld id="{60C89CFB-3BD4-45D4-8FCC-79850387BF7C}" type="datetimeFigureOut">
               <a:rPr kumimoji="1" lang="ja-JP" altLang="en-US" smtClean="0"/>
-              <a:t>2025/10/29</a:t>
+              <a:t>2026/3/7</a:t>
             </a:fld>
             <a:endParaRPr kumimoji="1" lang="ja-JP" altLang="en-US"/>
           </a:p>
@@ -913,7 +913,7 @@
           <a:p>
             <a:fld id="{60C89CFB-3BD4-45D4-8FCC-79850387BF7C}" type="datetimeFigureOut">
               <a:rPr kumimoji="1" lang="ja-JP" altLang="en-US" smtClean="0"/>
-              <a:t>2025/10/29</a:t>
+              <a:t>2026/3/7</a:t>
             </a:fld>
             <a:endParaRPr kumimoji="1" lang="ja-JP" altLang="en-US"/>
           </a:p>
@@ -1125,7 +1125,7 @@
           <a:p>
             <a:fld id="{60C89CFB-3BD4-45D4-8FCC-79850387BF7C}" type="datetimeFigureOut">
               <a:rPr kumimoji="1" lang="ja-JP" altLang="en-US" smtClean="0"/>
-              <a:t>2025/10/29</a:t>
+              <a:t>2026/3/7</a:t>
             </a:fld>
             <a:endParaRPr kumimoji="1" lang="ja-JP" altLang="en-US"/>
           </a:p>
@@ -1327,7 +1327,7 @@
           <a:p>
             <a:fld id="{60C89CFB-3BD4-45D4-8FCC-79850387BF7C}" type="datetimeFigureOut">
               <a:rPr kumimoji="1" lang="ja-JP" altLang="en-US" smtClean="0"/>
-              <a:t>2025/10/29</a:t>
+              <a:t>2026/3/7</a:t>
             </a:fld>
             <a:endParaRPr kumimoji="1" lang="ja-JP" altLang="en-US"/>
           </a:p>
@@ -1573,7 +1573,7 @@
           <a:p>
             <a:fld id="{60C89CFB-3BD4-45D4-8FCC-79850387BF7C}" type="datetimeFigureOut">
               <a:rPr kumimoji="1" lang="ja-JP" altLang="en-US" smtClean="0"/>
-              <a:t>2025/10/29</a:t>
+              <a:t>2026/3/7</a:t>
             </a:fld>
             <a:endParaRPr kumimoji="1" lang="ja-JP" altLang="en-US"/>
           </a:p>
@@ -1869,7 +1869,7 @@
           <a:p>
             <a:fld id="{60C89CFB-3BD4-45D4-8FCC-79850387BF7C}" type="datetimeFigureOut">
               <a:rPr kumimoji="1" lang="ja-JP" altLang="en-US" smtClean="0"/>
-              <a:t>2025/10/29</a:t>
+              <a:t>2026/3/7</a:t>
             </a:fld>
             <a:endParaRPr kumimoji="1" lang="ja-JP" altLang="en-US"/>
           </a:p>
@@ -2300,7 +2300,7 @@
           <a:p>
             <a:fld id="{60C89CFB-3BD4-45D4-8FCC-79850387BF7C}" type="datetimeFigureOut">
               <a:rPr kumimoji="1" lang="ja-JP" altLang="en-US" smtClean="0"/>
-              <a:t>2025/10/29</a:t>
+              <a:t>2026/3/7</a:t>
             </a:fld>
             <a:endParaRPr kumimoji="1" lang="ja-JP" altLang="en-US"/>
           </a:p>
@@ -2418,7 +2418,7 @@
           <a:p>
             <a:fld id="{60C89CFB-3BD4-45D4-8FCC-79850387BF7C}" type="datetimeFigureOut">
               <a:rPr kumimoji="1" lang="ja-JP" altLang="en-US" smtClean="0"/>
-              <a:t>2025/10/29</a:t>
+              <a:t>2026/3/7</a:t>
             </a:fld>
             <a:endParaRPr kumimoji="1" lang="ja-JP" altLang="en-US"/>
           </a:p>
@@ -2513,7 +2513,7 @@
           <a:p>
             <a:fld id="{60C89CFB-3BD4-45D4-8FCC-79850387BF7C}" type="datetimeFigureOut">
               <a:rPr kumimoji="1" lang="ja-JP" altLang="en-US" smtClean="0"/>
-              <a:t>2025/10/29</a:t>
+              <a:t>2026/3/7</a:t>
             </a:fld>
             <a:endParaRPr kumimoji="1" lang="ja-JP" altLang="en-US"/>
           </a:p>
@@ -2822,7 +2822,7 @@
           <a:p>
             <a:fld id="{60C89CFB-3BD4-45D4-8FCC-79850387BF7C}" type="datetimeFigureOut">
               <a:rPr kumimoji="1" lang="ja-JP" altLang="en-US" smtClean="0"/>
-              <a:t>2025/10/29</a:t>
+              <a:t>2026/3/7</a:t>
             </a:fld>
             <a:endParaRPr kumimoji="1" lang="ja-JP" altLang="en-US"/>
           </a:p>
@@ -3079,7 +3079,7 @@
           <a:p>
             <a:fld id="{60C89CFB-3BD4-45D4-8FCC-79850387BF7C}" type="datetimeFigureOut">
               <a:rPr kumimoji="1" lang="ja-JP" altLang="en-US" smtClean="0"/>
-              <a:t>2025/10/29</a:t>
+              <a:t>2026/3/7</a:t>
             </a:fld>
             <a:endParaRPr kumimoji="1" lang="ja-JP" altLang="en-US"/>
           </a:p>
@@ -3324,7 +3324,7 @@
           <a:p>
             <a:fld id="{60C89CFB-3BD4-45D4-8FCC-79850387BF7C}" type="datetimeFigureOut">
               <a:rPr kumimoji="1" lang="ja-JP" altLang="en-US" smtClean="0"/>
-              <a:t>2025/10/29</a:t>
+              <a:t>2026/3/7</a:t>
             </a:fld>
             <a:endParaRPr kumimoji="1" lang="ja-JP" altLang="en-US"/>
           </a:p>
@@ -3883,7 +3883,47 @@
                   <a:latin typeface="Times New Roman" panose="02020603050405020304" pitchFamily="18" charset="0"/>
                   <a:cs typeface="Times New Roman" panose="02020603050405020304" pitchFamily="18" charset="0"/>
                 </a:rPr>
-                <a:t>Response (N = 6,142)</a:t>
+                <a:t>Positive</a:t>
+              </a:r>
+              <a:r>
+                <a:rPr lang="ja-JP" altLang="en-US" sz="1350" b="1" dirty="0">
+                  <a:solidFill>
+                    <a:schemeClr val="tx1"/>
+                  </a:solidFill>
+                  <a:latin typeface="Times New Roman" panose="02020603050405020304" pitchFamily="18" charset="0"/>
+                  <a:cs typeface="Times New Roman" panose="02020603050405020304" pitchFamily="18" charset="0"/>
+                </a:rPr>
+                <a:t> </a:t>
+              </a:r>
+              <a:r>
+                <a:rPr lang="en-US" altLang="ja-JP" sz="1350" b="1" dirty="0">
+                  <a:solidFill>
+                    <a:schemeClr val="tx1"/>
+                  </a:solidFill>
+                  <a:latin typeface="Times New Roman" panose="02020603050405020304" pitchFamily="18" charset="0"/>
+                  <a:cs typeface="Times New Roman" panose="02020603050405020304" pitchFamily="18" charset="0"/>
+                </a:rPr>
+                <a:t>Intention </a:t>
+              </a:r>
+              <a:r>
+                <a:rPr lang="en-US" altLang="ja-JP" sz="1350" b="1">
+                  <a:solidFill>
+                    <a:schemeClr val="tx1"/>
+                  </a:solidFill>
+                  <a:latin typeface="Times New Roman" panose="02020603050405020304" pitchFamily="18" charset="0"/>
+                  <a:cs typeface="Times New Roman" panose="02020603050405020304" pitchFamily="18" charset="0"/>
+                </a:rPr>
+                <a:t>at Response </a:t>
+              </a:r>
+              <a:r>
+                <a:rPr lang="en-US" altLang="ja-JP" sz="1350" b="1" dirty="0">
+                  <a:solidFill>
+                    <a:schemeClr val="tx1"/>
+                  </a:solidFill>
+                  <a:latin typeface="Times New Roman" panose="02020603050405020304" pitchFamily="18" charset="0"/>
+                  <a:cs typeface="Times New Roman" panose="02020603050405020304" pitchFamily="18" charset="0"/>
+                </a:rPr>
+                <a:t>(N = 6,143)</a:t>
               </a:r>
             </a:p>
             <a:p>
@@ -4112,7 +4152,27 @@
                   <a:latin typeface="Times New Roman" panose="02020603050405020304" pitchFamily="18" charset="0"/>
                   <a:cs typeface="Times New Roman" panose="02020603050405020304" pitchFamily="18" charset="0"/>
                 </a:rPr>
-                <a:t>CT [Primary Outcome] (N = 2,651)</a:t>
+                <a:t>CT </a:t>
+              </a:r>
+              <a:r>
+                <a:rPr lang="en-US" altLang="ja-JP" sz="1350" b="1">
+                  <a:solidFill>
+                    <a:schemeClr val="tx1"/>
+                  </a:solidFill>
+                  <a:latin typeface="Times New Roman" panose="02020603050405020304" pitchFamily="18" charset="0"/>
+                  <a:cs typeface="Times New Roman" panose="02020603050405020304" pitchFamily="18" charset="0"/>
+                </a:rPr>
+                <a:t>[Primary Outcome</a:t>
+              </a:r>
+              <a:r>
+                <a:rPr lang="en-US" altLang="ja-JP" sz="1350" b="1" dirty="0">
+                  <a:solidFill>
+                    <a:schemeClr val="tx1"/>
+                  </a:solidFill>
+                  <a:latin typeface="Times New Roman" panose="02020603050405020304" pitchFamily="18" charset="0"/>
+                  <a:cs typeface="Times New Roman" panose="02020603050405020304" pitchFamily="18" charset="0"/>
+                </a:rPr>
+                <a:t>] (N = 2,653)</a:t>
               </a:r>
             </a:p>
             <a:p>
@@ -4908,8 +4968,8 @@
           </p:nvSpPr>
           <p:spPr>
             <a:xfrm>
-              <a:off x="5610707" y="3767347"/>
-              <a:ext cx="1906092" cy="440874"/>
+              <a:off x="5610706" y="3695942"/>
+              <a:ext cx="3317287" cy="908051"/>
             </a:xfrm>
             <a:prstGeom prst="roundRect">
               <a:avLst/>
@@ -4952,15 +5012,40 @@
                   <a:latin typeface="Times New Roman" panose="02020603050405020304" pitchFamily="18" charset="0"/>
                   <a:cs typeface="Times New Roman" panose="02020603050405020304" pitchFamily="18" charset="0"/>
                 </a:rPr>
-                <a:t>Dropout (N = 3,491)</a:t>
+                <a:t>Dropout (N = 3,490)</a:t>
               </a:r>
-              <a:endParaRPr lang="en-US" altLang="ja-JP" sz="1350" dirty="0">
-                <a:solidFill>
-                  <a:schemeClr val="tx1"/>
-                </a:solidFill>
-                <a:latin typeface="Times New Roman" panose="02020603050405020304" pitchFamily="18" charset="0"/>
-                <a:cs typeface="Times New Roman" panose="02020603050405020304" pitchFamily="18" charset="0"/>
-              </a:endParaRPr>
+            </a:p>
+            <a:p>
+              <a:pPr marL="285750" indent="-285750">
+                <a:buFont typeface="Arial" panose="020B0604020202020204" pitchFamily="34" charset="0"/>
+                <a:buChar char="•"/>
+              </a:pPr>
+              <a:r>
+                <a:rPr lang="en-US" altLang="ja-JP" sz="1350" dirty="0">
+                  <a:solidFill>
+                    <a:schemeClr val="tx1"/>
+                  </a:solidFill>
+                  <a:latin typeface="Times New Roman" panose="02020603050405020304" pitchFamily="18" charset="0"/>
+                  <a:cs typeface="Times New Roman" panose="02020603050405020304" pitchFamily="18" charset="0"/>
+                </a:rPr>
+                <a:t>Donor-related dropout (N = 2,940)</a:t>
+              </a:r>
+            </a:p>
+            <a:p>
+              <a:pPr marL="285750" indent="-285750">
+                <a:buFont typeface="Arial" panose="020B0604020202020204" pitchFamily="34" charset="0"/>
+                <a:buChar char="•"/>
+              </a:pPr>
+              <a:r>
+                <a:rPr lang="en-US" altLang="ja-JP" sz="1350" dirty="0">
+                  <a:solidFill>
+                    <a:schemeClr val="tx1"/>
+                  </a:solidFill>
+                  <a:latin typeface="Times New Roman" panose="02020603050405020304" pitchFamily="18" charset="0"/>
+                  <a:cs typeface="Times New Roman" panose="02020603050405020304" pitchFamily="18" charset="0"/>
+                </a:rPr>
+                <a:t>Patient-related dropout (N = 550) </a:t>
+              </a:r>
             </a:p>
           </p:txBody>
         </p:sp>
@@ -4975,14 +5060,13 @@
             </p:cNvPr>
             <p:cNvCxnSpPr>
               <a:cxnSpLocks/>
-              <a:endCxn id="96" idx="1"/>
             </p:cNvCxnSpPr>
             <p:nvPr/>
           </p:nvCxnSpPr>
           <p:spPr>
-            <a:xfrm>
-              <a:off x="2864931" y="3982214"/>
-              <a:ext cx="2745776" cy="5570"/>
+            <a:xfrm flipV="1">
+              <a:off x="2864931" y="3982195"/>
+              <a:ext cx="2745775" cy="19"/>
             </a:xfrm>
             <a:prstGeom prst="straightConnector1">
               <a:avLst/>
@@ -5068,7 +5152,7 @@
                   <a:latin typeface="Times New Roman" panose="02020603050405020304" pitchFamily="18" charset="0"/>
                   <a:cs typeface="Times New Roman" panose="02020603050405020304" pitchFamily="18" charset="0"/>
                 </a:rPr>
-                <a:t>Dropout (N = 1,950)</a:t>
+                <a:t>Dropout (N = 1,952)</a:t>
               </a:r>
               <a:endParaRPr lang="en-US" altLang="ja-JP" sz="1350" dirty="0">
                 <a:solidFill>

</xml_diff>

<commit_message>
Update main document and LaTeX files to reflect revised statistics on donor coordinations, including updated counts and percentages for positive intention, donation rates, and demographic details. Adjust flowchart data to ensure accuracy in dropout and selection figures. Render updated documents.
</commit_message>
<xml_diff>
--- a/image/flowchart.pptx
+++ b/image/flowchart.pptx
@@ -197,7 +197,7 @@
           <a:p>
             <a:fld id="{AE391BAF-91F8-4B50-BA74-917754362F3D}" type="datetimeFigureOut">
               <a:rPr kumimoji="1" lang="ja-JP" altLang="en-US" smtClean="0"/>
-              <a:t>2026/3/7</a:t>
+              <a:t>2026/3/28</a:t>
             </a:fld>
             <a:endParaRPr kumimoji="1" lang="ja-JP" altLang="en-US"/>
           </a:p>
@@ -711,7 +711,7 @@
           <a:p>
             <a:fld id="{60C89CFB-3BD4-45D4-8FCC-79850387BF7C}" type="datetimeFigureOut">
               <a:rPr kumimoji="1" lang="ja-JP" altLang="en-US" smtClean="0"/>
-              <a:t>2026/3/7</a:t>
+              <a:t>2026/3/28</a:t>
             </a:fld>
             <a:endParaRPr kumimoji="1" lang="ja-JP" altLang="en-US"/>
           </a:p>
@@ -913,7 +913,7 @@
           <a:p>
             <a:fld id="{60C89CFB-3BD4-45D4-8FCC-79850387BF7C}" type="datetimeFigureOut">
               <a:rPr kumimoji="1" lang="ja-JP" altLang="en-US" smtClean="0"/>
-              <a:t>2026/3/7</a:t>
+              <a:t>2026/3/28</a:t>
             </a:fld>
             <a:endParaRPr kumimoji="1" lang="ja-JP" altLang="en-US"/>
           </a:p>
@@ -1125,7 +1125,7 @@
           <a:p>
             <a:fld id="{60C89CFB-3BD4-45D4-8FCC-79850387BF7C}" type="datetimeFigureOut">
               <a:rPr kumimoji="1" lang="ja-JP" altLang="en-US" smtClean="0"/>
-              <a:t>2026/3/7</a:t>
+              <a:t>2026/3/28</a:t>
             </a:fld>
             <a:endParaRPr kumimoji="1" lang="ja-JP" altLang="en-US"/>
           </a:p>
@@ -1327,7 +1327,7 @@
           <a:p>
             <a:fld id="{60C89CFB-3BD4-45D4-8FCC-79850387BF7C}" type="datetimeFigureOut">
               <a:rPr kumimoji="1" lang="ja-JP" altLang="en-US" smtClean="0"/>
-              <a:t>2026/3/7</a:t>
+              <a:t>2026/3/28</a:t>
             </a:fld>
             <a:endParaRPr kumimoji="1" lang="ja-JP" altLang="en-US"/>
           </a:p>
@@ -1573,7 +1573,7 @@
           <a:p>
             <a:fld id="{60C89CFB-3BD4-45D4-8FCC-79850387BF7C}" type="datetimeFigureOut">
               <a:rPr kumimoji="1" lang="ja-JP" altLang="en-US" smtClean="0"/>
-              <a:t>2026/3/7</a:t>
+              <a:t>2026/3/28</a:t>
             </a:fld>
             <a:endParaRPr kumimoji="1" lang="ja-JP" altLang="en-US"/>
           </a:p>
@@ -1869,7 +1869,7 @@
           <a:p>
             <a:fld id="{60C89CFB-3BD4-45D4-8FCC-79850387BF7C}" type="datetimeFigureOut">
               <a:rPr kumimoji="1" lang="ja-JP" altLang="en-US" smtClean="0"/>
-              <a:t>2026/3/7</a:t>
+              <a:t>2026/3/28</a:t>
             </a:fld>
             <a:endParaRPr kumimoji="1" lang="ja-JP" altLang="en-US"/>
           </a:p>
@@ -2300,7 +2300,7 @@
           <a:p>
             <a:fld id="{60C89CFB-3BD4-45D4-8FCC-79850387BF7C}" type="datetimeFigureOut">
               <a:rPr kumimoji="1" lang="ja-JP" altLang="en-US" smtClean="0"/>
-              <a:t>2026/3/7</a:t>
+              <a:t>2026/3/28</a:t>
             </a:fld>
             <a:endParaRPr kumimoji="1" lang="ja-JP" altLang="en-US"/>
           </a:p>
@@ -2418,7 +2418,7 @@
           <a:p>
             <a:fld id="{60C89CFB-3BD4-45D4-8FCC-79850387BF7C}" type="datetimeFigureOut">
               <a:rPr kumimoji="1" lang="ja-JP" altLang="en-US" smtClean="0"/>
-              <a:t>2026/3/7</a:t>
+              <a:t>2026/3/28</a:t>
             </a:fld>
             <a:endParaRPr kumimoji="1" lang="ja-JP" altLang="en-US"/>
           </a:p>
@@ -2513,7 +2513,7 @@
           <a:p>
             <a:fld id="{60C89CFB-3BD4-45D4-8FCC-79850387BF7C}" type="datetimeFigureOut">
               <a:rPr kumimoji="1" lang="ja-JP" altLang="en-US" smtClean="0"/>
-              <a:t>2026/3/7</a:t>
+              <a:t>2026/3/28</a:t>
             </a:fld>
             <a:endParaRPr kumimoji="1" lang="ja-JP" altLang="en-US"/>
           </a:p>
@@ -2822,7 +2822,7 @@
           <a:p>
             <a:fld id="{60C89CFB-3BD4-45D4-8FCC-79850387BF7C}" type="datetimeFigureOut">
               <a:rPr kumimoji="1" lang="ja-JP" altLang="en-US" smtClean="0"/>
-              <a:t>2026/3/7</a:t>
+              <a:t>2026/3/28</a:t>
             </a:fld>
             <a:endParaRPr kumimoji="1" lang="ja-JP" altLang="en-US"/>
           </a:p>
@@ -3079,7 +3079,7 @@
           <a:p>
             <a:fld id="{60C89CFB-3BD4-45D4-8FCC-79850387BF7C}" type="datetimeFigureOut">
               <a:rPr kumimoji="1" lang="ja-JP" altLang="en-US" smtClean="0"/>
-              <a:t>2026/3/7</a:t>
+              <a:t>2026/3/28</a:t>
             </a:fld>
             <a:endParaRPr kumimoji="1" lang="ja-JP" altLang="en-US"/>
           </a:p>
@@ -3324,7 +3324,7 @@
           <a:p>
             <a:fld id="{60C89CFB-3BD4-45D4-8FCC-79850387BF7C}" type="datetimeFigureOut">
               <a:rPr kumimoji="1" lang="ja-JP" altLang="en-US" smtClean="0"/>
-              <a:t>2026/3/7</a:t>
+              <a:t>2026/3/28</a:t>
             </a:fld>
             <a:endParaRPr kumimoji="1" lang="ja-JP" altLang="en-US"/>
           </a:p>
@@ -3903,27 +3903,7 @@
                   <a:latin typeface="Times New Roman" panose="02020603050405020304" pitchFamily="18" charset="0"/>
                   <a:cs typeface="Times New Roman" panose="02020603050405020304" pitchFamily="18" charset="0"/>
                 </a:rPr>
-                <a:t>Intention </a:t>
-              </a:r>
-              <a:r>
-                <a:rPr lang="en-US" altLang="ja-JP" sz="1350" b="1">
-                  <a:solidFill>
-                    <a:schemeClr val="tx1"/>
-                  </a:solidFill>
-                  <a:latin typeface="Times New Roman" panose="02020603050405020304" pitchFamily="18" charset="0"/>
-                  <a:cs typeface="Times New Roman" panose="02020603050405020304" pitchFamily="18" charset="0"/>
-                </a:rPr>
-                <a:t>at Response </a:t>
-              </a:r>
-              <a:r>
-                <a:rPr lang="en-US" altLang="ja-JP" sz="1350" b="1" dirty="0">
-                  <a:solidFill>
-                    <a:schemeClr val="tx1"/>
-                  </a:solidFill>
-                  <a:latin typeface="Times New Roman" panose="02020603050405020304" pitchFamily="18" charset="0"/>
-                  <a:cs typeface="Times New Roman" panose="02020603050405020304" pitchFamily="18" charset="0"/>
-                </a:rPr>
-                <a:t>(N = 6,143)</a:t>
+                <a:t>Intention at Response (N = 6,142)</a:t>
               </a:r>
             </a:p>
             <a:p>
@@ -4152,27 +4132,7 @@
                   <a:latin typeface="Times New Roman" panose="02020603050405020304" pitchFamily="18" charset="0"/>
                   <a:cs typeface="Times New Roman" panose="02020603050405020304" pitchFamily="18" charset="0"/>
                 </a:rPr>
-                <a:t>CT </a:t>
-              </a:r>
-              <a:r>
-                <a:rPr lang="en-US" altLang="ja-JP" sz="1350" b="1">
-                  <a:solidFill>
-                    <a:schemeClr val="tx1"/>
-                  </a:solidFill>
-                  <a:latin typeface="Times New Roman" panose="02020603050405020304" pitchFamily="18" charset="0"/>
-                  <a:cs typeface="Times New Roman" panose="02020603050405020304" pitchFamily="18" charset="0"/>
-                </a:rPr>
-                <a:t>[Primary Outcome</a:t>
-              </a:r>
-              <a:r>
-                <a:rPr lang="en-US" altLang="ja-JP" sz="1350" b="1" dirty="0">
-                  <a:solidFill>
-                    <a:schemeClr val="tx1"/>
-                  </a:solidFill>
-                  <a:latin typeface="Times New Roman" panose="02020603050405020304" pitchFamily="18" charset="0"/>
-                  <a:cs typeface="Times New Roman" panose="02020603050405020304" pitchFamily="18" charset="0"/>
-                </a:rPr>
-                <a:t>] (N = 2,653)</a:t>
+                <a:t>CT [Primary Outcome] (N = 2,650)</a:t>
               </a:r>
             </a:p>
             <a:p>
@@ -4248,7 +4208,7 @@
                   <a:latin typeface="Times New Roman" panose="02020603050405020304" pitchFamily="18" charset="0"/>
                   <a:cs typeface="Times New Roman" panose="02020603050405020304" pitchFamily="18" charset="0"/>
                 </a:rPr>
-                <a:t>Final Selection (N = 701)</a:t>
+                <a:t>Final Selection (N = 698)</a:t>
               </a:r>
             </a:p>
             <a:p>
@@ -4324,7 +4284,7 @@
                   <a:latin typeface="Times New Roman" panose="02020603050405020304" pitchFamily="18" charset="0"/>
                   <a:cs typeface="Times New Roman" panose="02020603050405020304" pitchFamily="18" charset="0"/>
                 </a:rPr>
-                <a:t>Donation (N = 503)</a:t>
+                <a:t>Donation (N = 501)</a:t>
               </a:r>
             </a:p>
             <a:p>
@@ -5012,7 +4972,7 @@
                   <a:latin typeface="Times New Roman" panose="02020603050405020304" pitchFamily="18" charset="0"/>
                   <a:cs typeface="Times New Roman" panose="02020603050405020304" pitchFamily="18" charset="0"/>
                 </a:rPr>
-                <a:t>Dropout (N = 3,490)</a:t>
+                <a:t>Dropout (N = 3,492)</a:t>
               </a:r>
             </a:p>
             <a:p>
@@ -5028,7 +4988,7 @@
                   <a:latin typeface="Times New Roman" panose="02020603050405020304" pitchFamily="18" charset="0"/>
                   <a:cs typeface="Times New Roman" panose="02020603050405020304" pitchFamily="18" charset="0"/>
                 </a:rPr>
-                <a:t>Donor-related dropout (N = 2,940)</a:t>
+                <a:t>Donor-related dropout (N = 2,942)</a:t>
               </a:r>
             </a:p>
             <a:p>
@@ -5268,7 +5228,7 @@
                   <a:latin typeface="Times New Roman" panose="02020603050405020304" pitchFamily="18" charset="0"/>
                   <a:cs typeface="Times New Roman" panose="02020603050405020304" pitchFamily="18" charset="0"/>
                 </a:rPr>
-                <a:t>Dropout (N = 198)</a:t>
+                <a:t>Dropout (N = 197)</a:t>
               </a:r>
             </a:p>
             <a:p>
@@ -5360,8 +5320,25 @@
                   <a:latin typeface="Times New Roman" panose="02020603050405020304" pitchFamily="18" charset="0"/>
                   <a:cs typeface="Times New Roman" panose="02020603050405020304" pitchFamily="18" charset="0"/>
                 </a:rPr>
-                <a:t>Dropout after final consent (N = 124)</a:t>
+                <a:t>Dropout after final consent (N </a:t>
               </a:r>
+              <a:r>
+                <a:rPr lang="en-US" altLang="ja-JP" sz="1350">
+                  <a:solidFill>
+                    <a:schemeClr val="tx1"/>
+                  </a:solidFill>
+                  <a:latin typeface="Times New Roman" panose="02020603050405020304" pitchFamily="18" charset="0"/>
+                  <a:cs typeface="Times New Roman" panose="02020603050405020304" pitchFamily="18" charset="0"/>
+                </a:rPr>
+                <a:t>= 123)</a:t>
+              </a:r>
+              <a:endParaRPr lang="en-US" altLang="ja-JP" sz="1350" dirty="0">
+                <a:solidFill>
+                  <a:schemeClr val="tx1"/>
+                </a:solidFill>
+                <a:latin typeface="Times New Roman" panose="02020603050405020304" pitchFamily="18" charset="0"/>
+                <a:cs typeface="Times New Roman" panose="02020603050405020304" pitchFamily="18" charset="0"/>
+              </a:endParaRPr>
             </a:p>
           </p:txBody>
         </p:sp>

</xml_diff>